<commit_message>
sql skill added to skill section in persian version
</commit_message>
<xml_diff>
--- a/Persian/CV.pptx
+++ b/Persian/CV.pptx
@@ -314,7 +314,7 @@
           <a:p>
             <a:fld id="{64A32902-01AF-440E-9C03-193C4F014EE4}" type="datetimeFigureOut">
               <a:rPr lang="en-US" smtClean="0"/>
-              <a:t>6/8/2026</a:t>
+              <a:t>6/9/2026</a:t>
             </a:fld>
             <a:endParaRPr lang="en-US"/>
           </a:p>
@@ -504,7 +504,7 @@
           <a:p>
             <a:fld id="{64A32902-01AF-440E-9C03-193C4F014EE4}" type="datetimeFigureOut">
               <a:rPr lang="en-US" smtClean="0"/>
-              <a:t>6/8/2026</a:t>
+              <a:t>6/9/2026</a:t>
             </a:fld>
             <a:endParaRPr lang="en-US"/>
           </a:p>
@@ -684,7 +684,7 @@
           <a:p>
             <a:fld id="{64A32902-01AF-440E-9C03-193C4F014EE4}" type="datetimeFigureOut">
               <a:rPr lang="en-US" smtClean="0"/>
-              <a:t>6/8/2026</a:t>
+              <a:t>6/9/2026</a:t>
             </a:fld>
             <a:endParaRPr lang="en-US"/>
           </a:p>
@@ -854,7 +854,7 @@
           <a:p>
             <a:fld id="{64A32902-01AF-440E-9C03-193C4F014EE4}" type="datetimeFigureOut">
               <a:rPr lang="en-US" smtClean="0"/>
-              <a:t>6/8/2026</a:t>
+              <a:t>6/9/2026</a:t>
             </a:fld>
             <a:endParaRPr lang="en-US"/>
           </a:p>
@@ -1110,7 +1110,7 @@
           <a:p>
             <a:fld id="{64A32902-01AF-440E-9C03-193C4F014EE4}" type="datetimeFigureOut">
               <a:rPr lang="en-US" smtClean="0"/>
-              <a:t>6/8/2026</a:t>
+              <a:t>6/9/2026</a:t>
             </a:fld>
             <a:endParaRPr lang="en-US"/>
           </a:p>
@@ -1398,7 +1398,7 @@
           <a:p>
             <a:fld id="{64A32902-01AF-440E-9C03-193C4F014EE4}" type="datetimeFigureOut">
               <a:rPr lang="en-US" smtClean="0"/>
-              <a:t>6/8/2026</a:t>
+              <a:t>6/9/2026</a:t>
             </a:fld>
             <a:endParaRPr lang="en-US"/>
           </a:p>
@@ -1836,7 +1836,7 @@
           <a:p>
             <a:fld id="{64A32902-01AF-440E-9C03-193C4F014EE4}" type="datetimeFigureOut">
               <a:rPr lang="en-US" smtClean="0"/>
-              <a:t>6/8/2026</a:t>
+              <a:t>6/9/2026</a:t>
             </a:fld>
             <a:endParaRPr lang="en-US"/>
           </a:p>
@@ -1954,7 +1954,7 @@
           <a:p>
             <a:fld id="{64A32902-01AF-440E-9C03-193C4F014EE4}" type="datetimeFigureOut">
               <a:rPr lang="en-US" smtClean="0"/>
-              <a:t>6/8/2026</a:t>
+              <a:t>6/9/2026</a:t>
             </a:fld>
             <a:endParaRPr lang="en-US"/>
           </a:p>
@@ -2049,7 +2049,7 @@
           <a:p>
             <a:fld id="{64A32902-01AF-440E-9C03-193C4F014EE4}" type="datetimeFigureOut">
               <a:rPr lang="en-US" smtClean="0"/>
-              <a:t>6/8/2026</a:t>
+              <a:t>6/9/2026</a:t>
             </a:fld>
             <a:endParaRPr lang="en-US"/>
           </a:p>
@@ -2405,7 +2405,7 @@
           <a:p>
             <a:fld id="{64A32902-01AF-440E-9C03-193C4F014EE4}" type="datetimeFigureOut">
               <a:rPr lang="en-US" smtClean="0"/>
-              <a:t>6/8/2026</a:t>
+              <a:t>6/9/2026</a:t>
             </a:fld>
             <a:endParaRPr lang="en-US"/>
           </a:p>
@@ -2724,7 +2724,7 @@
           <a:p>
             <a:fld id="{64A32902-01AF-440E-9C03-193C4F014EE4}" type="datetimeFigureOut">
               <a:rPr lang="en-US" smtClean="0"/>
-              <a:t>6/8/2026</a:t>
+              <a:t>6/9/2026</a:t>
             </a:fld>
             <a:endParaRPr lang="en-US"/>
           </a:p>
@@ -2957,7 +2957,7 @@
           <a:p>
             <a:fld id="{64A32902-01AF-440E-9C03-193C4F014EE4}" type="datetimeFigureOut">
               <a:rPr lang="en-US" smtClean="0"/>
-              <a:t>6/8/2026</a:t>
+              <a:t>6/9/2026</a:t>
             </a:fld>
             <a:endParaRPr lang="en-US"/>
           </a:p>
@@ -3594,13 +3594,19 @@
             <a:p>
               <a:pPr algn="r" rtl="1"/>
               <a:r>
-                <a:rPr lang="en-US" sz="1100" dirty="0">
+                <a:rPr lang="en-US" sz="1100" b="1" dirty="0">
+                  <a:solidFill>
+                    <a:schemeClr val="tx1"/>
+                  </a:solidFill>
                   <a:cs typeface="B Lotus" panose="00000400000000000000" pitchFamily="2" charset="-78"/>
                 </a:rPr>
                 <a:t>📱</a:t>
               </a:r>
               <a:r>
-                <a:rPr lang="fa-IR" sz="1100" dirty="0">
+                <a:rPr lang="fa-IR" sz="1100" b="1" dirty="0">
+                  <a:solidFill>
+                    <a:srgbClr val="FFFFFF"/>
+                  </a:solidFill>
                   <a:cs typeface="B Lotus" panose="00000400000000000000" pitchFamily="2" charset="-78"/>
                 </a:rPr>
                 <a:t>09223848714</a:t>
@@ -3609,19 +3615,28 @@
             <a:p>
               <a:pPr algn="r" rtl="1"/>
               <a:r>
-                <a:rPr lang="fa-IR" sz="1100" dirty="0">
+                <a:rPr lang="fa-IR" sz="1100" b="1" dirty="0">
+                  <a:solidFill>
+                    <a:schemeClr val="tx1"/>
+                  </a:solidFill>
                   <a:cs typeface="B Lotus" panose="00000400000000000000" pitchFamily="2" charset="-78"/>
                 </a:rPr>
                 <a:t>📧</a:t>
               </a:r>
               <a:r>
-                <a:rPr lang="en-US" sz="1100" dirty="0">
+                <a:rPr lang="en-US" sz="1100" b="1" dirty="0">
+                  <a:solidFill>
+                    <a:srgbClr val="FFFFFF"/>
+                  </a:solidFill>
                   <a:latin typeface="Bodoni MT Condensed" panose="02070606080606020203" pitchFamily="18" charset="0"/>
                   <a:cs typeface="B Lotus" panose="00000400000000000000" pitchFamily="2" charset="-78"/>
                 </a:rPr>
                 <a:t>mehrdadmrs10@gmail.com</a:t>
               </a:r>
-              <a:endParaRPr lang="fa-IR" sz="1100" dirty="0">
+              <a:endParaRPr lang="fa-IR" sz="1100" b="1" dirty="0">
+                <a:solidFill>
+                  <a:srgbClr val="FFFFFF"/>
+                </a:solidFill>
                 <a:latin typeface="Bodoni MT Condensed" panose="02070606080606020203" pitchFamily="18" charset="0"/>
                 <a:cs typeface="B Lotus" panose="00000400000000000000" pitchFamily="2" charset="-78"/>
               </a:endParaRPr>
@@ -3629,55 +3644,91 @@
             <a:p>
               <a:pPr algn="r" rtl="1"/>
               <a:r>
-                <a:rPr lang="fa-IR" sz="1100" dirty="0">
+                <a:rPr lang="fa-IR" sz="1100" b="1" dirty="0">
+                  <a:solidFill>
+                    <a:schemeClr val="tx1"/>
+                  </a:solidFill>
                   <a:cs typeface="B Lotus" panose="00000400000000000000" pitchFamily="2" charset="-78"/>
                 </a:rPr>
-                <a:t>🏠همدان ، منطقه 1</a:t>
+                <a:t>🏠</a:t>
+              </a:r>
+              <a:r>
+                <a:rPr lang="fa-IR" sz="1100" b="1" dirty="0">
+                  <a:solidFill>
+                    <a:srgbClr val="FFFFFF"/>
+                  </a:solidFill>
+                  <a:cs typeface="B Lotus" panose="00000400000000000000" pitchFamily="2" charset="-78"/>
+                </a:rPr>
+                <a:t>همدان ، منطقه 1</a:t>
               </a:r>
               <a:br>
-                <a:rPr lang="fa-IR" sz="1100" dirty="0">
+                <a:rPr lang="fa-IR" sz="1100" b="1" dirty="0">
+                  <a:solidFill>
+                    <a:srgbClr val="FFFFFF"/>
+                  </a:solidFill>
                   <a:cs typeface="B Lotus" panose="00000400000000000000" pitchFamily="2" charset="-78"/>
                 </a:rPr>
               </a:br>
               <a:r>
-                <a:rPr lang="en-US" sz="1100" dirty="0">
+                <a:rPr lang="en-US" sz="1100" b="1" dirty="0">
+                  <a:solidFill>
+                    <a:srgbClr val="FFFFFF"/>
+                  </a:solidFill>
                   <a:cs typeface="B Lotus" panose="00000400000000000000" pitchFamily="2" charset="-78"/>
                 </a:rPr>
                 <a:t>   </a:t>
               </a:r>
               <a:r>
-                <a:rPr lang="fa-IR" sz="1100" dirty="0">
+                <a:rPr lang="fa-IR" sz="1100" b="1" dirty="0">
+                  <a:solidFill>
+                    <a:srgbClr val="FFFFFF"/>
+                  </a:solidFill>
                   <a:cs typeface="B Lotus" panose="00000400000000000000" pitchFamily="2" charset="-78"/>
                 </a:rPr>
                 <a:t>   </a:t>
               </a:r>
               <a:r>
-                <a:rPr lang="en-US" sz="1100" dirty="0">
+                <a:rPr lang="en-US" sz="1100" b="1" dirty="0">
+                  <a:solidFill>
+                    <a:srgbClr val="FFFFFF"/>
+                  </a:solidFill>
                   <a:latin typeface="Bodoni MT Condensed" panose="02070606080606020203" pitchFamily="18" charset="0"/>
                   <a:cs typeface="B Lotus" panose="00000400000000000000" pitchFamily="2" charset="-78"/>
                 </a:rPr>
                 <a:t>Mehrdad_383</a:t>
               </a:r>
               <a:br>
-                <a:rPr lang="fa-IR" sz="1100" dirty="0">
+                <a:rPr lang="fa-IR" sz="1100" b="1" dirty="0">
+                  <a:solidFill>
+                    <a:srgbClr val="FFFFFF"/>
+                  </a:solidFill>
                   <a:latin typeface="Bodoni MT Condensed" panose="02070606080606020203" pitchFamily="18" charset="0"/>
                   <a:cs typeface="B Lotus" panose="00000400000000000000" pitchFamily="2" charset="-78"/>
                 </a:rPr>
               </a:br>
               <a:r>
-                <a:rPr lang="en-US" sz="1100" dirty="0">
+                <a:rPr lang="en-US" sz="1100" b="1" dirty="0">
+                  <a:solidFill>
+                    <a:srgbClr val="FFFFFF"/>
+                  </a:solidFill>
                   <a:cs typeface="B Lotus" panose="00000400000000000000" pitchFamily="2" charset="-78"/>
                 </a:rPr>
                 <a:t>     </a:t>
               </a:r>
               <a:r>
-                <a:rPr lang="fa-IR" sz="1100" dirty="0">
+                <a:rPr lang="fa-IR" sz="1100" b="1" dirty="0">
+                  <a:solidFill>
+                    <a:srgbClr val="FFFFFF"/>
+                  </a:solidFill>
                   <a:cs typeface="B Lotus" panose="00000400000000000000" pitchFamily="2" charset="-78"/>
                 </a:rPr>
                 <a:t> </a:t>
               </a:r>
               <a:r>
-                <a:rPr lang="en-US" sz="1100" dirty="0">
+                <a:rPr lang="en-US" sz="1100" b="1" dirty="0">
+                  <a:solidFill>
+                    <a:srgbClr val="FFFFFF"/>
+                  </a:solidFill>
                   <a:latin typeface="Bodoni MT Condensed" panose="02070606080606020203" pitchFamily="18" charset="0"/>
                   <a:cs typeface="B Lotus" panose="00000400000000000000" pitchFamily="2" charset="-78"/>
                 </a:rPr>
@@ -3687,20 +3738,29 @@
             <a:p>
               <a:pPr algn="r" rtl="1"/>
               <a:r>
-                <a:rPr lang="en-US" sz="1100" dirty="0">
+                <a:rPr lang="en-US" sz="1100" b="1" dirty="0">
+                  <a:solidFill>
+                    <a:srgbClr val="FFFFFF"/>
+                  </a:solidFill>
                   <a:latin typeface="Bodoni MT Condensed" panose="02070606080606020203" pitchFamily="18" charset="0"/>
                   <a:cs typeface="B Lotus" panose="00000400000000000000" pitchFamily="2" charset="-78"/>
                 </a:rPr>
                 <a:t>Mehrdad386       </a:t>
               </a:r>
               <a:r>
-                <a:rPr lang="fa-IR" sz="1100" dirty="0">
+                <a:rPr lang="fa-IR" sz="1100" b="1" dirty="0">
+                  <a:solidFill>
+                    <a:srgbClr val="FFFFFF"/>
+                  </a:solidFill>
                   <a:latin typeface="Bodoni MT Condensed" panose="02070606080606020203" pitchFamily="18" charset="0"/>
                   <a:cs typeface="B Lotus" panose="00000400000000000000" pitchFamily="2" charset="-78"/>
                 </a:rPr>
                 <a:t>  </a:t>
               </a:r>
-              <a:endParaRPr lang="en-US" sz="1100" dirty="0">
+              <a:endParaRPr lang="en-US" sz="1100" b="1" dirty="0">
+                <a:solidFill>
+                  <a:srgbClr val="FFFFFF"/>
+                </a:solidFill>
                 <a:latin typeface="Bodoni MT Condensed" panose="02070606080606020203" pitchFamily="18" charset="0"/>
                 <a:cs typeface="B Lotus" panose="00000400000000000000" pitchFamily="2" charset="-78"/>
               </a:endParaRPr>
@@ -3915,8 +3975,8 @@
         </p:nvSpPr>
         <p:spPr>
           <a:xfrm>
-            <a:off x="4777194" y="5998780"/>
-            <a:ext cx="1784007" cy="1169551"/>
+            <a:off x="4278203" y="5998780"/>
+            <a:ext cx="2579797" cy="861774"/>
           </a:xfrm>
           <a:prstGeom prst="rect">
             <a:avLst/>
@@ -3982,12 +4042,15 @@
                 </a:solidFill>
                 <a:cs typeface="B Lotus" panose="00000400000000000000" pitchFamily="2" charset="-78"/>
               </a:rPr>
-              <a:t>  🟩🟩🟩🟩🟩</a:t>
+              <a:t>  </a:t>
+            </a:r>
+            <a:r>
+              <a:rPr lang="fa-IR" sz="1000" dirty="0">
+                <a:cs typeface="B Lotus" panose="00000400000000000000" pitchFamily="2" charset="-78"/>
+              </a:rPr>
+              <a:t>🟩🟩🟩🟩🟩</a:t>
             </a:r>
             <a:endParaRPr lang="en-US" sz="1000" dirty="0">
-              <a:solidFill>
-                <a:srgbClr val="FFFFFF"/>
-              </a:solidFill>
               <a:cs typeface="B Lotus" panose="00000400000000000000" pitchFamily="2" charset="-78"/>
             </a:endParaRPr>
           </a:p>
@@ -4012,7 +4075,13 @@
                 </a:solidFill>
                 <a:cs typeface="B Lotus" panose="00000400000000000000" pitchFamily="2" charset="-78"/>
               </a:rPr>
-              <a:t> 🟩🟩🟩⬜⬜</a:t>
+              <a:t> </a:t>
+            </a:r>
+            <a:r>
+              <a:rPr lang="fa-IR" sz="1000" dirty="0">
+                <a:cs typeface="B Lotus" panose="00000400000000000000" pitchFamily="2" charset="-78"/>
+              </a:rPr>
+              <a:t>🟩🟩🟩⬜⬜</a:t>
             </a:r>
           </a:p>
           <a:p>
@@ -4052,8 +4121,8 @@
         </p:nvSpPr>
         <p:spPr>
           <a:xfrm>
-            <a:off x="4777194" y="6872698"/>
-            <a:ext cx="1784007" cy="707886"/>
+            <a:off x="4278203" y="6580598"/>
+            <a:ext cx="2579797" cy="553998"/>
           </a:xfrm>
           <a:prstGeom prst="rect">
             <a:avLst/>
@@ -4119,7 +4188,13 @@
                 </a:solidFill>
                 <a:cs typeface="B Lotus" panose="00000400000000000000" pitchFamily="2" charset="-78"/>
               </a:rPr>
-              <a:t> 🟩🟩🟩⬜⬜</a:t>
+              <a:t> </a:t>
+            </a:r>
+            <a:r>
+              <a:rPr lang="fa-IR" sz="1000" dirty="0">
+                <a:cs typeface="B Lotus" panose="00000400000000000000" pitchFamily="2" charset="-78"/>
+              </a:rPr>
+              <a:t>🟩🟩🟩⬜⬜</a:t>
             </a:r>
           </a:p>
           <a:p>
@@ -4150,8 +4225,8 @@
         </p:nvSpPr>
         <p:spPr>
           <a:xfrm>
-            <a:off x="4777194" y="7376935"/>
-            <a:ext cx="1784007" cy="1015663"/>
+            <a:off x="4278203" y="6976885"/>
+            <a:ext cx="2579797" cy="707886"/>
           </a:xfrm>
           <a:prstGeom prst="rect">
             <a:avLst/>
@@ -4217,7 +4292,13 @@
                 </a:solidFill>
                 <a:cs typeface="B Lotus" panose="00000400000000000000" pitchFamily="2" charset="-78"/>
               </a:rPr>
-              <a:t> 🟩🟩🟩⬜⬜</a:t>
+              <a:t> </a:t>
+            </a:r>
+            <a:r>
+              <a:rPr lang="fa-IR" sz="1000" dirty="0">
+                <a:cs typeface="B Lotus" panose="00000400000000000000" pitchFamily="2" charset="-78"/>
+              </a:rPr>
+              <a:t>🟩🟩🟩⬜⬜</a:t>
             </a:r>
           </a:p>
           <a:p>
@@ -4241,7 +4322,13 @@
                 </a:solidFill>
                 <a:cs typeface="B Lotus" panose="00000400000000000000" pitchFamily="2" charset="-78"/>
               </a:rPr>
-              <a:t> ⬜⬜⬜⬜⬜</a:t>
+              <a:t> </a:t>
+            </a:r>
+            <a:r>
+              <a:rPr lang="fa-IR" sz="1000" dirty="0">
+                <a:cs typeface="B Lotus" panose="00000400000000000000" pitchFamily="2" charset="-78"/>
+              </a:rPr>
+              <a:t>⬜⬜⬜⬜⬜</a:t>
             </a:r>
           </a:p>
           <a:p>
@@ -4272,8 +4359,8 @@
         </p:nvSpPr>
         <p:spPr>
           <a:xfrm>
-            <a:off x="4777193" y="8247259"/>
-            <a:ext cx="1784007" cy="707886"/>
+            <a:off x="4278203" y="7547048"/>
+            <a:ext cx="2579796" cy="553998"/>
           </a:xfrm>
           <a:prstGeom prst="rect">
             <a:avLst/>
@@ -4321,7 +4408,13 @@
                 </a:solidFill>
                 <a:cs typeface="B Lotus" panose="00000400000000000000" pitchFamily="2" charset="-78"/>
               </a:rPr>
-              <a:t> 🟩🟩🟩🟩🟩</a:t>
+              <a:t> </a:t>
+            </a:r>
+            <a:r>
+              <a:rPr lang="fa-IR" sz="1000" dirty="0">
+                <a:cs typeface="B Lotus" panose="00000400000000000000" pitchFamily="2" charset="-78"/>
+              </a:rPr>
+              <a:t>🟩🟩🟩🟩🟩</a:t>
             </a:r>
           </a:p>
           <a:p>
@@ -4352,8 +4445,8 @@
         </p:nvSpPr>
         <p:spPr>
           <a:xfrm>
-            <a:off x="4760180" y="8782274"/>
-            <a:ext cx="1784007" cy="553998"/>
+            <a:off x="4278203" y="7931374"/>
+            <a:ext cx="2579797" cy="400110"/>
           </a:xfrm>
           <a:prstGeom prst="rect">
             <a:avLst/>
@@ -4401,7 +4494,13 @@
                 </a:solidFill>
                 <a:cs typeface="B Lotus" panose="00000400000000000000" pitchFamily="2" charset="-78"/>
               </a:rPr>
-              <a:t>  🟩🟩🟩🟩⬜</a:t>
+              <a:t>  </a:t>
+            </a:r>
+            <a:r>
+              <a:rPr lang="fa-IR" sz="1000" dirty="0">
+                <a:cs typeface="B Lotus" panose="00000400000000000000" pitchFamily="2" charset="-78"/>
+              </a:rPr>
+              <a:t>🟩🟩🟩🟩⬜</a:t>
             </a:r>
           </a:p>
         </p:txBody>
@@ -5248,8 +5347,8 @@
         </p:nvSpPr>
         <p:spPr>
           <a:xfrm>
-            <a:off x="4719748" y="9336272"/>
-            <a:ext cx="1784007" cy="553998"/>
+            <a:off x="4278203" y="8352022"/>
+            <a:ext cx="2579797" cy="400110"/>
           </a:xfrm>
           <a:prstGeom prst="rect">
             <a:avLst/>
@@ -5297,7 +5396,13 @@
                 </a:solidFill>
                 <a:cs typeface="B Lotus" panose="00000400000000000000" pitchFamily="2" charset="-78"/>
               </a:rPr>
-              <a:t> 🟩🟩🟩🟩⬜</a:t>
+              <a:t> </a:t>
+            </a:r>
+            <a:r>
+              <a:rPr lang="fa-IR" sz="1000" dirty="0">
+                <a:cs typeface="B Lotus" panose="00000400000000000000" pitchFamily="2" charset="-78"/>
+              </a:rPr>
+              <a:t>🟩🟩🟩🟩⬜</a:t>
             </a:r>
           </a:p>
         </p:txBody>
@@ -5756,6 +5861,98 @@
                 <a:cs typeface="B Lotus" panose="00000400000000000000" pitchFamily="2" charset="-78"/>
               </a:rPr>
               <a:t>آشنایی با منطق و سیستم توسعه بازی های کامپیوتری</a:t>
+            </a:r>
+          </a:p>
+        </p:txBody>
+      </p:sp>
+      <p:sp>
+        <p:nvSpPr>
+          <p:cNvPr id="35" name="TextBox 34">
+            <a:extLst>
+              <a:ext uri="{FF2B5EF4-FFF2-40B4-BE49-F238E27FC236}">
+                <a16:creationId xmlns:a16="http://schemas.microsoft.com/office/drawing/2014/main" id="{D51DF2FE-200D-4EA8-A16D-A191611BD0D6}"/>
+              </a:ext>
+            </a:extLst>
+          </p:cNvPr>
+          <p:cNvSpPr txBox="1"/>
+          <p:nvPr/>
+        </p:nvSpPr>
+        <p:spPr>
+          <a:xfrm>
+            <a:off x="4278202" y="8918385"/>
+            <a:ext cx="2579797" cy="400110"/>
+          </a:xfrm>
+          <a:prstGeom prst="rect">
+            <a:avLst/>
+          </a:prstGeom>
+          <a:noFill/>
+        </p:spPr>
+        <p:txBody>
+          <a:bodyPr wrap="square" rtlCol="0">
+            <a:spAutoFit/>
+          </a:bodyPr>
+          <a:lstStyle/>
+          <a:p>
+            <a:pPr marL="171450" indent="-171450" algn="r" rtl="1">
+              <a:buFont typeface="Arial" panose="020B0604020202020204" pitchFamily="34" charset="0"/>
+              <a:buChar char="•"/>
+            </a:pPr>
+            <a:r>
+              <a:rPr lang="fa-IR" sz="1000" dirty="0">
+                <a:solidFill>
+                  <a:srgbClr val="FFFFFF"/>
+                </a:solidFill>
+                <a:cs typeface="B Lotus" panose="00000400000000000000" pitchFamily="2" charset="-78"/>
+              </a:rPr>
+              <a:t>طراحی پایگاه داده ( </a:t>
+            </a:r>
+            <a:r>
+              <a:rPr lang="en-US" sz="1000" dirty="0">
+                <a:solidFill>
+                  <a:srgbClr val="FFFFFF"/>
+                </a:solidFill>
+                <a:cs typeface="B Lotus" panose="00000400000000000000" pitchFamily="2" charset="-78"/>
+              </a:rPr>
+              <a:t>SQL</a:t>
+            </a:r>
+            <a:r>
+              <a:rPr lang="fa-IR" sz="1000" dirty="0">
+                <a:solidFill>
+                  <a:srgbClr val="FFFFFF"/>
+                </a:solidFill>
+                <a:cs typeface="B Lotus" panose="00000400000000000000" pitchFamily="2" charset="-78"/>
+              </a:rPr>
+              <a:t> )</a:t>
+            </a:r>
+          </a:p>
+          <a:p>
+            <a:pPr marL="628650" lvl="1" indent="-171450" algn="r" rtl="1">
+              <a:buFont typeface="Arial" panose="020B0604020202020204" pitchFamily="34" charset="0"/>
+              <a:buChar char="•"/>
+            </a:pPr>
+            <a:r>
+              <a:rPr lang="en-US" sz="1000" dirty="0" err="1">
+                <a:solidFill>
+                  <a:srgbClr val="FFFFFF"/>
+                </a:solidFill>
+                <a:cs typeface="B Lotus" panose="00000400000000000000" pitchFamily="2" charset="-78"/>
+              </a:rPr>
+              <a:t>Postgresql</a:t>
+            </a:r>
+            <a:r>
+              <a:rPr lang="fa-IR" sz="1000" dirty="0">
+                <a:solidFill>
+                  <a:srgbClr val="FFFFFF"/>
+                </a:solidFill>
+                <a:cs typeface="B Lotus" panose="00000400000000000000" pitchFamily="2" charset="-78"/>
+              </a:rPr>
+              <a:t> </a:t>
+            </a:r>
+            <a:r>
+              <a:rPr lang="fa-IR" sz="1000" dirty="0">
+                <a:cs typeface="B Lotus" panose="00000400000000000000" pitchFamily="2" charset="-78"/>
+              </a:rPr>
+              <a:t>🟩🟩🟩🟩⬜</a:t>
             </a:r>
           </a:p>
         </p:txBody>

</xml_diff>

<commit_message>
new project added to persian CV
</commit_message>
<xml_diff>
--- a/Persian/CV.pptx
+++ b/Persian/CV.pptx
@@ -7671,6 +7671,160 @@
           </a:p>
         </p:txBody>
       </p:sp>
+      <p:sp>
+        <p:nvSpPr>
+          <p:cNvPr id="5" name="Rectangle 4">
+            <a:extLst>
+              <a:ext uri="{FF2B5EF4-FFF2-40B4-BE49-F238E27FC236}">
+                <a16:creationId xmlns:a16="http://schemas.microsoft.com/office/drawing/2014/main" id="{9F86DA20-4AE8-45F1-88B0-0D5D234498A0}"/>
+              </a:ext>
+            </a:extLst>
+          </p:cNvPr>
+          <p:cNvSpPr/>
+          <p:nvPr/>
+        </p:nvSpPr>
+        <p:spPr>
+          <a:xfrm>
+            <a:off x="603065" y="3576925"/>
+            <a:ext cx="2617208" cy="2093378"/>
+          </a:xfrm>
+          <a:prstGeom prst="rect">
+            <a:avLst/>
+          </a:prstGeom>
+          <a:solidFill>
+            <a:srgbClr val="F03B5E"/>
+          </a:solidFill>
+          <a:ln>
+            <a:solidFill>
+              <a:schemeClr val="tx1"/>
+            </a:solidFill>
+          </a:ln>
+        </p:spPr>
+        <p:style>
+          <a:lnRef idx="1">
+            <a:schemeClr val="accent1"/>
+          </a:lnRef>
+          <a:fillRef idx="2">
+            <a:schemeClr val="accent1"/>
+          </a:fillRef>
+          <a:effectRef idx="1">
+            <a:schemeClr val="accent1"/>
+          </a:effectRef>
+          <a:fontRef idx="minor">
+            <a:schemeClr val="dk1"/>
+          </a:fontRef>
+        </p:style>
+        <p:txBody>
+          <a:bodyPr rtlCol="0" anchor="ctr"/>
+          <a:lstStyle/>
+          <a:p>
+            <a:pPr algn="ctr" rtl="1"/>
+            <a:r>
+              <a:rPr lang="en-US" sz="1400" b="1" dirty="0">
+                <a:latin typeface="Bodoni MT Condensed" panose="02070606080606020203" pitchFamily="18" charset="0"/>
+                <a:cs typeface="B Lotus" panose="00000400000000000000" pitchFamily="2" charset="-78"/>
+              </a:rPr>
+              <a:t>DBMS Storage manager</a:t>
+            </a:r>
+            <a:endParaRPr lang="fa-IR" sz="1400" b="1" dirty="0">
+              <a:latin typeface="Bodoni MT Condensed" panose="02070606080606020203" pitchFamily="18" charset="0"/>
+              <a:cs typeface="B Lotus" panose="00000400000000000000" pitchFamily="2" charset="-78"/>
+            </a:endParaRPr>
+          </a:p>
+          <a:p>
+            <a:pPr algn="r" rtl="1"/>
+            <a:endParaRPr lang="en-US" sz="1400" b="1" dirty="0">
+              <a:latin typeface="Bodoni MT Condensed" panose="02070606080606020203" pitchFamily="18" charset="0"/>
+              <a:cs typeface="B Lotus" panose="00000400000000000000" pitchFamily="2" charset="-78"/>
+            </a:endParaRPr>
+          </a:p>
+          <a:p>
+            <a:pPr algn="r" rtl="1"/>
+            <a:r>
+              <a:rPr lang="fa-IR" sz="1100" dirty="0">
+                <a:latin typeface="Bodoni MT Condensed" panose="02070606080606020203" pitchFamily="18" charset="0"/>
+                <a:cs typeface="B Lotus" panose="00000400000000000000" pitchFamily="2" charset="-78"/>
+              </a:rPr>
+              <a:t>کار فرما : پروژه دانشگاهی</a:t>
+            </a:r>
+          </a:p>
+          <a:p>
+            <a:pPr algn="r" rtl="1"/>
+            <a:r>
+              <a:rPr lang="fa-IR" sz="1100" dirty="0">
+                <a:latin typeface="Bodoni MT Condensed" panose="02070606080606020203" pitchFamily="18" charset="0"/>
+                <a:cs typeface="B Lotus" panose="00000400000000000000" pitchFamily="2" charset="-78"/>
+              </a:rPr>
+              <a:t>تاریخ : اردیبهشت 1405</a:t>
+            </a:r>
+          </a:p>
+          <a:p>
+            <a:pPr algn="r" rtl="1"/>
+            <a:r>
+              <a:rPr lang="fa-IR" sz="1100" dirty="0">
+                <a:latin typeface="Bodoni MT Condensed" panose="02070606080606020203" pitchFamily="18" charset="0"/>
+                <a:cs typeface="B Lotus" panose="00000400000000000000" pitchFamily="2" charset="-78"/>
+              </a:rPr>
+              <a:t>توضیحات : پیاده سازی سیستم مدریت پایگاه داده با زبان </a:t>
+            </a:r>
+            <a:r>
+              <a:rPr lang="en-US" sz="1100" dirty="0" err="1">
+                <a:latin typeface="Bodoni MT Condensed" panose="02070606080606020203" pitchFamily="18" charset="0"/>
+                <a:cs typeface="B Lotus" panose="00000400000000000000" pitchFamily="2" charset="-78"/>
+              </a:rPr>
+              <a:t>cpp</a:t>
+            </a:r>
+            <a:r>
+              <a:rPr lang="fa-IR" sz="1100" dirty="0">
+                <a:latin typeface="Bodoni MT Condensed" panose="02070606080606020203" pitchFamily="18" charset="0"/>
+                <a:cs typeface="B Lotus" panose="00000400000000000000" pitchFamily="2" charset="-78"/>
+              </a:rPr>
+              <a:t> ( مینی پروژه درس پیاده سازی سیستم های پایگاه داده)</a:t>
+            </a:r>
+          </a:p>
+          <a:p>
+            <a:pPr algn="r" rtl="1"/>
+            <a:r>
+              <a:rPr lang="fa-IR" sz="1100" dirty="0">
+                <a:latin typeface="Bodoni MT Condensed" panose="02070606080606020203" pitchFamily="18" charset="0"/>
+                <a:cs typeface="B Lotus" panose="00000400000000000000" pitchFamily="2" charset="-78"/>
+              </a:rPr>
+              <a:t>لینک :</a:t>
+            </a:r>
+            <a:endParaRPr lang="en-US" sz="1100" dirty="0">
+              <a:latin typeface="Bodoni MT Condensed" panose="02070606080606020203" pitchFamily="18" charset="0"/>
+              <a:cs typeface="B Lotus" panose="00000400000000000000" pitchFamily="2" charset="-78"/>
+            </a:endParaRPr>
+          </a:p>
+          <a:p>
+            <a:pPr algn="r" rtl="1"/>
+            <a:r>
+              <a:rPr lang="fa-IR" sz="1100" dirty="0">
+                <a:solidFill>
+                  <a:srgbClr val="002060"/>
+                </a:solidFill>
+                <a:latin typeface="Bodoni MT Condensed" panose="02070606080606020203" pitchFamily="18" charset="0"/>
+                <a:cs typeface="B Lotus" panose="00000400000000000000" pitchFamily="2" charset="-78"/>
+                <a:hlinkClick r:id="rId5">
+                  <a:extLst>
+                    <a:ext uri="{A12FA001-AC4F-418D-AE19-62706E023703}">
+                      <ahyp:hlinkClr xmlns:ahyp="http://schemas.microsoft.com/office/drawing/2018/hyperlinkcolor" val="tx"/>
+                    </a:ext>
+                  </a:extLst>
+                </a:hlinkClick>
+              </a:rPr>
+              <a:t>مشاهده پروژه</a:t>
+            </a:r>
+            <a:endParaRPr lang="fa-IR" sz="1100" dirty="0">
+              <a:solidFill>
+                <a:srgbClr val="002060"/>
+              </a:solidFill>
+              <a:latin typeface="Bodoni MT Condensed" panose="02070606080606020203" pitchFamily="18" charset="0"/>
+              <a:cs typeface="B Lotus" panose="00000400000000000000" pitchFamily="2" charset="-78"/>
+            </a:endParaRPr>
+          </a:p>
+        </p:txBody>
+      </p:sp>
     </p:spTree>
     <p:extLst>
       <p:ext uri="{BB962C8B-B14F-4D97-AF65-F5344CB8AC3E}">

</xml_diff>